<commit_message>
Use the supplied Foundation logo (white on dark, colour on light) in every logo slot
</commit_message>
<xml_diff>
--- a/templates/posts/october/2026-10-01-thu-ig-boubacar.pptx
+++ b/templates/posts/october/2026-10-01-thu-ig-boubacar.pptx
@@ -4219,92 +4219,33 @@
           </a:p>
         </p:txBody>
       </p:sp>
-      <p:sp>
-        <p:nvSpPr>
-          <p:cNvPr id="10" name="Oval 9"/>
-          <p:cNvSpPr/>
+      <p:pic>
+        <p:nvPicPr>
+          <p:cNvPr id="10" name="Picture 9" descr="foundation-logo-white.png"/>
+          <p:cNvPicPr>
+            <a:picLocks noChangeAspect="1"/>
+          </p:cNvPicPr>
           <p:nvPr/>
-        </p:nvSpPr>
-        <p:spPr>
-          <a:xfrm>
-            <a:off x="8667750" y="11239500"/>
-            <a:ext cx="857250" cy="857250"/>
-          </a:xfrm>
-          <a:prstGeom prst="ellipse">
-            <a:avLst/>
-          </a:prstGeom>
-          <a:noFill/>
-          <a:ln w="19050">
-            <a:solidFill>
-              <a:srgbClr val="F4F1EA"/>
-            </a:solidFill>
-          </a:ln>
-          <a:effectLst/>
-        </p:spPr>
-        <p:style>
-          <a:lnRef idx="1">
-            <a:schemeClr val="accent1"/>
-          </a:lnRef>
-          <a:fillRef idx="3">
-            <a:schemeClr val="accent1"/>
-          </a:fillRef>
-          <a:effectRef idx="2">
-            <a:schemeClr val="accent1"/>
-          </a:effectRef>
-          <a:fontRef idx="minor">
-            <a:schemeClr val="lt1"/>
-          </a:fontRef>
-        </p:style>
-        <p:txBody>
-          <a:bodyPr rtlCol="0" anchor="ctr"/>
-          <a:lstStyle/>
-          <a:p>
-            <a:pPr algn="ctr"/>
-          </a:p>
-        </p:txBody>
-      </p:sp>
-      <p:sp>
-        <p:nvSpPr>
-          <p:cNvPr id="11" name="TextBox 10"/>
-          <p:cNvSpPr txBox="1"/>
-          <p:nvPr/>
-        </p:nvSpPr>
-        <p:spPr>
-          <a:xfrm>
-            <a:off x="8667750" y="11239500"/>
-            <a:ext cx="857250" cy="857250"/>
+        </p:nvPicPr>
+        <p:blipFill>
+          <a:blip r:embed="rId3"/>
+          <a:stretch>
+            <a:fillRect/>
+          </a:stretch>
+        </p:blipFill>
+        <p:spPr>
+          <a:xfrm>
+            <a:off x="8571501" y="11239500"/>
+            <a:ext cx="953498" cy="857250"/>
           </a:xfrm>
           <a:prstGeom prst="rect">
             <a:avLst/>
           </a:prstGeom>
-          <a:noFill/>
-        </p:spPr>
-        <p:txBody>
-          <a:bodyPr wrap="square" lIns="0" rIns="0" tIns="0" bIns="0" anchor="ctr">
-            <a:spAutoFit/>
-          </a:bodyPr>
-          <a:lstStyle/>
-          <a:p>
-            <a:pPr algn="ctr">
-              <a:lnSpc>
-                <a:spcPct val="120000"/>
-              </a:lnSpc>
-            </a:pPr>
-            <a:r>
-              <a:rPr sz="1800" b="1" i="0">
-                <a:solidFill>
-                  <a:srgbClr val="F4F1EA"/>
-                </a:solidFill>
-                <a:latin typeface="Montserrat"/>
-              </a:rPr>
-              <a:t>LOGO</a:t>
-            </a:r>
-          </a:p>
-        </p:txBody>
-      </p:sp>
-      <p:sp>
-        <p:nvSpPr>
-          <p:cNvPr id="12" name="TextBox 11"/>
+        </p:spPr>
+      </p:pic>
+      <p:sp>
+        <p:nvSpPr>
+          <p:cNvPr id="11" name="TextBox 10"/>
           <p:cNvSpPr txBox="1"/>
           <p:nvPr/>
         </p:nvSpPr>
@@ -5443,92 +5384,33 @@
           </a:p>
         </p:txBody>
       </p:sp>
-      <p:sp>
-        <p:nvSpPr>
-          <p:cNvPr id="7" name="Oval 6"/>
-          <p:cNvSpPr/>
+      <p:pic>
+        <p:nvPicPr>
+          <p:cNvPr id="7" name="Picture 6" descr="foundation-logo-color.png"/>
+          <p:cNvPicPr>
+            <a:picLocks noChangeAspect="1"/>
+          </p:cNvPicPr>
           <p:nvPr/>
-        </p:nvSpPr>
-        <p:spPr>
-          <a:xfrm>
-            <a:off x="8667750" y="11239500"/>
-            <a:ext cx="857250" cy="857250"/>
-          </a:xfrm>
-          <a:prstGeom prst="ellipse">
-            <a:avLst/>
-          </a:prstGeom>
-          <a:noFill/>
-          <a:ln w="19050">
-            <a:solidFill>
-              <a:srgbClr val="22371F"/>
-            </a:solidFill>
-          </a:ln>
-          <a:effectLst/>
-        </p:spPr>
-        <p:style>
-          <a:lnRef idx="1">
-            <a:schemeClr val="accent1"/>
-          </a:lnRef>
-          <a:fillRef idx="3">
-            <a:schemeClr val="accent1"/>
-          </a:fillRef>
-          <a:effectRef idx="2">
-            <a:schemeClr val="accent1"/>
-          </a:effectRef>
-          <a:fontRef idx="minor">
-            <a:schemeClr val="lt1"/>
-          </a:fontRef>
-        </p:style>
-        <p:txBody>
-          <a:bodyPr rtlCol="0" anchor="ctr"/>
-          <a:lstStyle/>
-          <a:p>
-            <a:pPr algn="ctr"/>
-          </a:p>
-        </p:txBody>
-      </p:sp>
-      <p:sp>
-        <p:nvSpPr>
-          <p:cNvPr id="8" name="TextBox 7"/>
-          <p:cNvSpPr txBox="1"/>
-          <p:nvPr/>
-        </p:nvSpPr>
-        <p:spPr>
-          <a:xfrm>
-            <a:off x="8667750" y="11239500"/>
-            <a:ext cx="857250" cy="857250"/>
+        </p:nvPicPr>
+        <p:blipFill>
+          <a:blip r:embed="rId3"/>
+          <a:stretch>
+            <a:fillRect/>
+          </a:stretch>
+        </p:blipFill>
+        <p:spPr>
+          <a:xfrm>
+            <a:off x="8571501" y="11239500"/>
+            <a:ext cx="953498" cy="857250"/>
           </a:xfrm>
           <a:prstGeom prst="rect">
             <a:avLst/>
           </a:prstGeom>
-          <a:noFill/>
-        </p:spPr>
-        <p:txBody>
-          <a:bodyPr wrap="square" lIns="0" rIns="0" tIns="0" bIns="0" anchor="ctr">
-            <a:spAutoFit/>
-          </a:bodyPr>
-          <a:lstStyle/>
-          <a:p>
-            <a:pPr algn="ctr">
-              <a:lnSpc>
-                <a:spcPct val="120000"/>
-              </a:lnSpc>
-            </a:pPr>
-            <a:r>
-              <a:rPr sz="1800" b="1" i="0">
-                <a:solidFill>
-                  <a:srgbClr val="22371F"/>
-                </a:solidFill>
-                <a:latin typeface="Montserrat"/>
-              </a:rPr>
-              <a:t>LOGO</a:t>
-            </a:r>
-          </a:p>
-        </p:txBody>
-      </p:sp>
-      <p:sp>
-        <p:nvSpPr>
-          <p:cNvPr id="9" name="TextBox 8"/>
+        </p:spPr>
+      </p:pic>
+      <p:sp>
+        <p:nvSpPr>
+          <p:cNvPr id="8" name="TextBox 7"/>
           <p:cNvSpPr txBox="1"/>
           <p:nvPr/>
         </p:nvSpPr>

</xml_diff>